<commit_message>
Taqdimot: ilmiy rahbar (Olimov I.S.) va foydalanilgan adabiyotlar slaydi qo'shildi
</commit_message>
<xml_diff>
--- a/Abbos_taqdimot.pptx
+++ b/Abbos_taqdimot.pptx
@@ -18,6 +18,7 @@
     <p:sldId id="266" r:id="rId17"/>
     <p:sldId id="267" r:id="rId18"/>
     <p:sldId id="268" r:id="rId19"/>
+    <p:sldId id="269" r:id="rId20"/>
   </p:sldIdLst>
   <p:sldSz cx="12191695" cy="6858000" type="screen4x3"/>
   <p:notesSz cx="6858000" cy="9144000"/>
@@ -3549,7 +3550,7 @@
                 </a:solidFill>
                 <a:latin typeface="Calibri"/>
               </a:rPr>
-              <a:t>Ilmiy rahbar:  ____________________</a:t>
+              <a:t>Ilmiy rahbar:  Olimov I.S.</a:t>
             </a:r>
           </a:p>
         </p:txBody>
@@ -6743,6 +6744,508 @@
             <a:avLst/>
           </a:prstGeom>
           <a:solidFill>
+            <a:srgbClr val="FFFFFF"/>
+          </a:solidFill>
+          <a:ln>
+            <a:noFill/>
+          </a:ln>
+          <a:effectLst/>
+        </p:spPr>
+        <p:style>
+          <a:lnRef idx="1">
+            <a:schemeClr val="accent1"/>
+          </a:lnRef>
+          <a:fillRef idx="3">
+            <a:schemeClr val="accent1"/>
+          </a:fillRef>
+          <a:effectRef idx="2">
+            <a:schemeClr val="accent1"/>
+          </a:effectRef>
+          <a:fontRef idx="minor">
+            <a:schemeClr val="lt1"/>
+          </a:fontRef>
+        </p:style>
+        <p:txBody>
+          <a:bodyPr rtlCol="0" anchor="ctr"/>
+          <a:lstStyle/>
+          <a:p>
+            <a:pPr algn="ctr"/>
+          </a:p>
+        </p:txBody>
+      </p:sp>
+      <p:sp>
+        <p:nvSpPr>
+          <p:cNvPr id="3" name="Rectangle 2"/>
+          <p:cNvSpPr/>
+          <p:nvPr/>
+        </p:nvSpPr>
+        <p:spPr>
+          <a:xfrm>
+            <a:off x="0" y="0"/>
+            <a:ext cx="12191695" cy="1051560"/>
+          </a:xfrm>
+          <a:prstGeom prst="rect">
+            <a:avLst/>
+          </a:prstGeom>
+          <a:solidFill>
+            <a:srgbClr val="0F2C4A"/>
+          </a:solidFill>
+          <a:ln>
+            <a:noFill/>
+          </a:ln>
+          <a:effectLst/>
+        </p:spPr>
+        <p:style>
+          <a:lnRef idx="1">
+            <a:schemeClr val="accent1"/>
+          </a:lnRef>
+          <a:fillRef idx="3">
+            <a:schemeClr val="accent1"/>
+          </a:fillRef>
+          <a:effectRef idx="2">
+            <a:schemeClr val="accent1"/>
+          </a:effectRef>
+          <a:fontRef idx="minor">
+            <a:schemeClr val="lt1"/>
+          </a:fontRef>
+        </p:style>
+        <p:txBody>
+          <a:bodyPr rtlCol="0" anchor="ctr"/>
+          <a:lstStyle/>
+          <a:p>
+            <a:pPr algn="ctr"/>
+          </a:p>
+        </p:txBody>
+      </p:sp>
+      <p:sp>
+        <p:nvSpPr>
+          <p:cNvPr id="4" name="Rectangle 3"/>
+          <p:cNvSpPr/>
+          <p:nvPr/>
+        </p:nvSpPr>
+        <p:spPr>
+          <a:xfrm>
+            <a:off x="0" y="1051560"/>
+            <a:ext cx="12191695" cy="73152"/>
+          </a:xfrm>
+          <a:prstGeom prst="rect">
+            <a:avLst/>
+          </a:prstGeom>
+          <a:solidFill>
+            <a:srgbClr val="1C6EA4"/>
+          </a:solidFill>
+          <a:ln>
+            <a:noFill/>
+          </a:ln>
+          <a:effectLst/>
+        </p:spPr>
+        <p:style>
+          <a:lnRef idx="1">
+            <a:schemeClr val="accent1"/>
+          </a:lnRef>
+          <a:fillRef idx="3">
+            <a:schemeClr val="accent1"/>
+          </a:fillRef>
+          <a:effectRef idx="2">
+            <a:schemeClr val="accent1"/>
+          </a:effectRef>
+          <a:fontRef idx="minor">
+            <a:schemeClr val="lt1"/>
+          </a:fontRef>
+        </p:style>
+        <p:txBody>
+          <a:bodyPr rtlCol="0" anchor="ctr"/>
+          <a:lstStyle/>
+          <a:p>
+            <a:pPr algn="ctr"/>
+          </a:p>
+        </p:txBody>
+      </p:sp>
+      <p:sp>
+        <p:nvSpPr>
+          <p:cNvPr id="5" name="TextBox 4"/>
+          <p:cNvSpPr txBox="1"/>
+          <p:nvPr/>
+        </p:nvSpPr>
+        <p:spPr>
+          <a:xfrm>
+            <a:off x="548640" y="0"/>
+            <a:ext cx="10058400" cy="1051560"/>
+          </a:xfrm>
+          <a:prstGeom prst="rect">
+            <a:avLst/>
+          </a:prstGeom>
+          <a:noFill/>
+        </p:spPr>
+        <p:txBody>
+          <a:bodyPr wrap="square" anchor="ctr">
+            <a:spAutoFit/>
+          </a:bodyPr>
+          <a:lstStyle/>
+          <a:p>
+            <a:pPr algn="l"/>
+            <a:r>
+              <a:rPr sz="2600" b="1" i="0">
+                <a:solidFill>
+                  <a:srgbClr val="FFFFFF"/>
+                </a:solidFill>
+                <a:latin typeface="Calibri"/>
+              </a:rPr>
+              <a:t>Foydalanilgan adabiyotlar</a:t>
+            </a:r>
+          </a:p>
+        </p:txBody>
+      </p:sp>
+      <p:sp>
+        <p:nvSpPr>
+          <p:cNvPr id="6" name="Rectangle 5"/>
+          <p:cNvSpPr/>
+          <p:nvPr/>
+        </p:nvSpPr>
+        <p:spPr>
+          <a:xfrm>
+            <a:off x="11247120" y="292608"/>
+            <a:ext cx="457200" cy="457200"/>
+          </a:xfrm>
+          <a:prstGeom prst="rect">
+            <a:avLst/>
+          </a:prstGeom>
+          <a:solidFill>
+            <a:srgbClr val="1C6EA4"/>
+          </a:solidFill>
+          <a:ln>
+            <a:noFill/>
+          </a:ln>
+          <a:effectLst/>
+        </p:spPr>
+        <p:style>
+          <a:lnRef idx="1">
+            <a:schemeClr val="accent1"/>
+          </a:lnRef>
+          <a:fillRef idx="3">
+            <a:schemeClr val="accent1"/>
+          </a:fillRef>
+          <a:effectRef idx="2">
+            <a:schemeClr val="accent1"/>
+          </a:effectRef>
+          <a:fontRef idx="minor">
+            <a:schemeClr val="lt1"/>
+          </a:fontRef>
+        </p:style>
+        <p:txBody>
+          <a:bodyPr rtlCol="0" anchor="ctr"/>
+          <a:lstStyle/>
+          <a:p>
+            <a:pPr algn="ctr"/>
+          </a:p>
+        </p:txBody>
+      </p:sp>
+      <p:sp>
+        <p:nvSpPr>
+          <p:cNvPr id="7" name="TextBox 6"/>
+          <p:cNvSpPr txBox="1"/>
+          <p:nvPr/>
+        </p:nvSpPr>
+        <p:spPr>
+          <a:xfrm>
+            <a:off x="11247120" y="292608"/>
+            <a:ext cx="457200" cy="457200"/>
+          </a:xfrm>
+          <a:prstGeom prst="rect">
+            <a:avLst/>
+          </a:prstGeom>
+          <a:noFill/>
+        </p:spPr>
+        <p:txBody>
+          <a:bodyPr wrap="square" anchor="ctr">
+            <a:spAutoFit/>
+          </a:bodyPr>
+          <a:lstStyle/>
+          <a:p>
+            <a:pPr algn="ctr"/>
+            <a:r>
+              <a:rPr sz="1600" b="1" i="0">
+                <a:solidFill>
+                  <a:srgbClr val="FFFFFF"/>
+                </a:solidFill>
+                <a:latin typeface="Calibri"/>
+              </a:rPr>
+              <a:t>13</a:t>
+            </a:r>
+          </a:p>
+        </p:txBody>
+      </p:sp>
+      <p:sp>
+        <p:nvSpPr>
+          <p:cNvPr id="8" name="TextBox 7"/>
+          <p:cNvSpPr txBox="1"/>
+          <p:nvPr/>
+        </p:nvSpPr>
+        <p:spPr>
+          <a:xfrm>
+            <a:off x="640080" y="1371600"/>
+            <a:ext cx="5394960" cy="5120640"/>
+          </a:xfrm>
+          <a:prstGeom prst="rect">
+            <a:avLst/>
+          </a:prstGeom>
+          <a:noFill/>
+        </p:spPr>
+        <p:txBody>
+          <a:bodyPr wrap="square">
+            <a:spAutoFit/>
+          </a:bodyPr>
+          <a:lstStyle/>
+          <a:p>
+            <a:pPr algn="l">
+              <a:spcAft>
+                <a:spcPts val="1200"/>
+              </a:spcAft>
+            </a:pPr>
+            <a:r>
+              <a:rPr sz="1400">
+                <a:solidFill>
+                  <a:srgbClr val="444A52"/>
+                </a:solidFill>
+                <a:latin typeface="Calibri"/>
+              </a:rPr>
+              <a:t>1. O'zR Prezidenti Farmoni «O'zbekiston-2030 strategiyasi», PF-158, 2023.</a:t>
+            </a:r>
+          </a:p>
+          <a:p>
+            <a:pPr algn="l">
+              <a:spcAft>
+                <a:spcPts val="1200"/>
+              </a:spcAft>
+            </a:pPr>
+            <a:r>
+              <a:rPr sz="1400">
+                <a:solidFill>
+                  <a:srgbClr val="444A52"/>
+                </a:solidFill>
+                <a:latin typeface="Calibri"/>
+              </a:rPr>
+              <a:t>2. O'zR Prezidenti Qarori «Kriptologiya sohasida ta'lim va ilm-fan», PQ-293, 2024.</a:t>
+            </a:r>
+          </a:p>
+          <a:p>
+            <a:pPr algn="l">
+              <a:spcAft>
+                <a:spcPts val="1200"/>
+              </a:spcAft>
+            </a:pPr>
+            <a:r>
+              <a:rPr sz="1400">
+                <a:solidFill>
+                  <a:srgbClr val="444A52"/>
+                </a:solidFill>
+                <a:latin typeface="Calibri"/>
+              </a:rPr>
+              <a:t>3. O'zR «Kiberxavfsizlik to'g'risida»gi Qonuni, O'RQ-764, 2022.</a:t>
+            </a:r>
+          </a:p>
+          <a:p>
+            <a:pPr algn="l">
+              <a:spcAft>
+                <a:spcPts val="1200"/>
+              </a:spcAft>
+            </a:pPr>
+            <a:r>
+              <a:rPr sz="1400">
+                <a:solidFill>
+                  <a:srgbClr val="444A52"/>
+                </a:solidFill>
+                <a:latin typeface="Calibri"/>
+              </a:rPr>
+              <a:t>4. Menezes A., van Oorschot P., Vanstone S. Handbook of Applied Cryptography. CRC Press, 1996.</a:t>
+            </a:r>
+          </a:p>
+          <a:p>
+            <a:pPr algn="l">
+              <a:spcAft>
+                <a:spcPts val="1200"/>
+              </a:spcAft>
+            </a:pPr>
+            <a:r>
+              <a:rPr sz="1400">
+                <a:solidFill>
+                  <a:srgbClr val="444A52"/>
+                </a:solidFill>
+                <a:latin typeface="Calibri"/>
+              </a:rPr>
+              <a:t>5. Stallings W. Cryptography and Network Security. 8th ed. Pearson, 2020.</a:t>
+            </a:r>
+          </a:p>
+          <a:p>
+            <a:pPr algn="l">
+              <a:spcAft>
+                <a:spcPts val="1200"/>
+              </a:spcAft>
+            </a:pPr>
+            <a:r>
+              <a:rPr sz="1400">
+                <a:solidFill>
+                  <a:srgbClr val="444A52"/>
+                </a:solidFill>
+                <a:latin typeface="Calibri"/>
+              </a:rPr>
+              <a:t>6. Diffie W., Hellman M. New Directions in Cryptography // IEEE Trans. Inf. Theory, 1976.</a:t>
+            </a:r>
+          </a:p>
+        </p:txBody>
+      </p:sp>
+      <p:sp>
+        <p:nvSpPr>
+          <p:cNvPr id="9" name="TextBox 8"/>
+          <p:cNvSpPr txBox="1"/>
+          <p:nvPr/>
+        </p:nvSpPr>
+        <p:spPr>
+          <a:xfrm>
+            <a:off x="6263640" y="1371600"/>
+            <a:ext cx="5394960" cy="5120640"/>
+          </a:xfrm>
+          <a:prstGeom prst="rect">
+            <a:avLst/>
+          </a:prstGeom>
+          <a:noFill/>
+        </p:spPr>
+        <p:txBody>
+          <a:bodyPr wrap="square">
+            <a:spAutoFit/>
+          </a:bodyPr>
+          <a:lstStyle/>
+          <a:p>
+            <a:pPr algn="l">
+              <a:spcAft>
+                <a:spcPts val="1200"/>
+              </a:spcAft>
+            </a:pPr>
+            <a:r>
+              <a:rPr sz="1400">
+                <a:solidFill>
+                  <a:srgbClr val="444A52"/>
+                </a:solidFill>
+                <a:latin typeface="Calibri"/>
+              </a:rPr>
+              <a:t>7. NIST. Lightweight Cryptography: NIST Selects Ascon. NIST IR 8454, 2023.</a:t>
+            </a:r>
+          </a:p>
+          <a:p>
+            <a:pPr algn="l">
+              <a:spcAft>
+                <a:spcPts val="1200"/>
+              </a:spcAft>
+            </a:pPr>
+            <a:r>
+              <a:rPr sz="1400">
+                <a:solidFill>
+                  <a:srgbClr val="444A52"/>
+                </a:solidFill>
+                <a:latin typeface="Calibri"/>
+              </a:rPr>
+              <a:t>8. NIST. FIPS 186-5: Digital Signature Standard (DSS), 2023.</a:t>
+            </a:r>
+          </a:p>
+          <a:p>
+            <a:pPr algn="l">
+              <a:spcAft>
+                <a:spcPts val="1200"/>
+              </a:spcAft>
+            </a:pPr>
+            <a:r>
+              <a:rPr sz="1400">
+                <a:solidFill>
+                  <a:srgbClr val="444A52"/>
+                </a:solidFill>
+                <a:latin typeface="Calibri"/>
+              </a:rPr>
+              <a:t>9. NIST. FIPS 180-4: Secure Hash Standard (SHS), 2015.</a:t>
+            </a:r>
+          </a:p>
+          <a:p>
+            <a:pPr algn="l">
+              <a:spcAft>
+                <a:spcPts val="1200"/>
+              </a:spcAft>
+            </a:pPr>
+            <a:r>
+              <a:rPr sz="1400">
+                <a:solidFill>
+                  <a:srgbClr val="444A52"/>
+                </a:solidFill>
+                <a:latin typeface="Calibri"/>
+              </a:rPr>
+              <a:t>10. NIST. FIPS 202: SHA-3 Standard, 2015.</a:t>
+            </a:r>
+          </a:p>
+          <a:p>
+            <a:pPr algn="l">
+              <a:spcAft>
+                <a:spcPts val="1200"/>
+              </a:spcAft>
+            </a:pPr>
+            <a:r>
+              <a:rPr sz="1400">
+                <a:solidFill>
+                  <a:srgbClr val="444A52"/>
+                </a:solidFill>
+                <a:latin typeface="Calibri"/>
+              </a:rPr>
+              <a:t>11. ISO/IEC 9797-1:2011. Message Authentication Codes (MACs) — Part 1.</a:t>
+            </a:r>
+          </a:p>
+          <a:p>
+            <a:pPr algn="l">
+              <a:spcAft>
+                <a:spcPts val="1200"/>
+              </a:spcAft>
+            </a:pPr>
+            <a:r>
+              <a:rPr sz="1400">
+                <a:solidFill>
+                  <a:srgbClr val="444A52"/>
+                </a:solidFill>
+                <a:latin typeface="Calibri"/>
+              </a:rPr>
+              <a:t>12. Bellare M., Canetti R., Krawczyk H. Keying Hash Functions for Message Authentication. CRYPTO '96.</a:t>
+            </a:r>
+          </a:p>
+        </p:txBody>
+      </p:sp>
+    </p:spTree>
+  </p:cSld>
+  <p:clrMapOvr>
+    <a:masterClrMapping/>
+  </p:clrMapOvr>
+</p:sld>
+</file>
+
+<file path=ppt/slides/slide14.xml><?xml version="1.0" encoding="utf-8"?>
+<p:sld xmlns:a="http://schemas.openxmlformats.org/drawingml/2006/main" xmlns:p="http://schemas.openxmlformats.org/presentationml/2006/main" xmlns:r="http://schemas.openxmlformats.org/officeDocument/2006/relationships">
+  <p:cSld>
+    <p:spTree>
+      <p:nvGrpSpPr>
+        <p:cNvPr id="1" name=""/>
+        <p:cNvGrpSpPr/>
+        <p:nvPr/>
+      </p:nvGrpSpPr>
+      <p:grpSpPr/>
+      <p:sp>
+        <p:nvSpPr>
+          <p:cNvPr id="2" name="Rectangle 1"/>
+          <p:cNvSpPr/>
+          <p:nvPr/>
+        </p:nvSpPr>
+        <p:spPr>
+          <a:xfrm>
+            <a:off x="0" y="0"/>
+            <a:ext cx="12191695" cy="6858000"/>
+          </a:xfrm>
+          <a:prstGeom prst="rect">
+            <a:avLst/>
+          </a:prstGeom>
+          <a:solidFill>
             <a:srgbClr val="0F2C4A"/>
           </a:solidFill>
           <a:ln>
@@ -8092,7 +8595,7 @@
                 </a:solidFill>
                 <a:latin typeface="Calibri"/>
               </a:rPr>
-              <a:t>Xulosa</a:t>
+              <a:t>Xulosa va foydalanilgan adabiyotlar</a:t>
             </a:r>
           </a:p>
         </p:txBody>

</xml_diff>

<commit_message>
Taqdimot: 4 va 5-slaydlar oralig'iga 'Yengil vaznli xesh funksiyalar nima?' slaydi qo'shildi
</commit_message>
<xml_diff>
--- a/Abbos_taqdimot.pptx
+++ b/Abbos_taqdimot.pptx
@@ -9,6 +9,7 @@
     <p:sldId id="258" r:id="rId3"/>
     <p:sldId id="260" r:id="rId4"/>
     <p:sldId id="261" r:id="rId5"/>
+    <p:sldId id="270" r:id="rId19"/>
     <p:sldId id="259" r:id="rId6"/>
     <p:sldId id="262" r:id="rId7"/>
     <p:sldId id="263" r:id="rId8"/>
@@ -5647,6 +5648,1705 @@
                 <a:latin typeface="Calibri"/>
               </a:rPr>
               <a:t>Axmadxo'jayev Abbosxon  •  Toshkent – 2026</a:t>
+            </a:r>
+          </a:p>
+        </p:txBody>
+      </p:sp>
+    </p:spTree>
+  </p:cSld>
+  <p:clrMapOvr>
+    <a:masterClrMapping/>
+  </p:clrMapOvr>
+</p:sld>
+</file>
+
+<file path=ppt/slides/slide14.xml><?xml version="1.0" encoding="utf-8"?>
+<p:sld xmlns:a="http://schemas.openxmlformats.org/drawingml/2006/main" xmlns:p="http://schemas.openxmlformats.org/presentationml/2006/main" xmlns:r="http://schemas.openxmlformats.org/officeDocument/2006/relationships">
+  <p:cSld>
+    <p:spTree>
+      <p:nvGrpSpPr>
+        <p:cNvPr id="1" name=""/>
+        <p:cNvGrpSpPr/>
+        <p:nvPr/>
+      </p:nvGrpSpPr>
+      <p:grpSpPr/>
+      <p:sp>
+        <p:nvSpPr>
+          <p:cNvPr id="2" name="Rectangle 1"/>
+          <p:cNvSpPr/>
+          <p:nvPr/>
+        </p:nvSpPr>
+        <p:spPr>
+          <a:xfrm>
+            <a:off x="0" y="0"/>
+            <a:ext cx="12191695" cy="6858000"/>
+          </a:xfrm>
+          <a:prstGeom prst="rect">
+            <a:avLst/>
+          </a:prstGeom>
+          <a:solidFill>
+            <a:srgbClr val="FFFFFF"/>
+          </a:solidFill>
+          <a:ln>
+            <a:noFill/>
+          </a:ln>
+          <a:effectLst/>
+        </p:spPr>
+        <p:style>
+          <a:lnRef idx="1">
+            <a:schemeClr val="accent1"/>
+          </a:lnRef>
+          <a:fillRef idx="3">
+            <a:schemeClr val="accent1"/>
+          </a:fillRef>
+          <a:effectRef idx="2">
+            <a:schemeClr val="accent1"/>
+          </a:effectRef>
+          <a:fontRef idx="minor">
+            <a:schemeClr val="lt1"/>
+          </a:fontRef>
+        </p:style>
+        <p:txBody>
+          <a:bodyPr rtlCol="0" anchor="ctr"/>
+          <a:lstStyle/>
+          <a:p>
+            <a:pPr algn="ctr"/>
+          </a:p>
+        </p:txBody>
+      </p:sp>
+      <p:sp>
+        <p:nvSpPr>
+          <p:cNvPr id="3" name="Rectangle 2"/>
+          <p:cNvSpPr/>
+          <p:nvPr/>
+        </p:nvSpPr>
+        <p:spPr>
+          <a:xfrm>
+            <a:off x="0" y="0"/>
+            <a:ext cx="12191695" cy="1051560"/>
+          </a:xfrm>
+          <a:prstGeom prst="rect">
+            <a:avLst/>
+          </a:prstGeom>
+          <a:solidFill>
+            <a:srgbClr val="0F2C4A"/>
+          </a:solidFill>
+          <a:ln>
+            <a:noFill/>
+          </a:ln>
+          <a:effectLst/>
+        </p:spPr>
+        <p:style>
+          <a:lnRef idx="1">
+            <a:schemeClr val="accent1"/>
+          </a:lnRef>
+          <a:fillRef idx="3">
+            <a:schemeClr val="accent1"/>
+          </a:fillRef>
+          <a:effectRef idx="2">
+            <a:schemeClr val="accent1"/>
+          </a:effectRef>
+          <a:fontRef idx="minor">
+            <a:schemeClr val="lt1"/>
+          </a:fontRef>
+        </p:style>
+        <p:txBody>
+          <a:bodyPr rtlCol="0" anchor="ctr"/>
+          <a:lstStyle/>
+          <a:p>
+            <a:pPr algn="ctr"/>
+          </a:p>
+        </p:txBody>
+      </p:sp>
+      <p:sp>
+        <p:nvSpPr>
+          <p:cNvPr id="4" name="Rectangle 3"/>
+          <p:cNvSpPr/>
+          <p:nvPr/>
+        </p:nvSpPr>
+        <p:spPr>
+          <a:xfrm>
+            <a:off x="0" y="1051560"/>
+            <a:ext cx="12191695" cy="73152"/>
+          </a:xfrm>
+          <a:prstGeom prst="rect">
+            <a:avLst/>
+          </a:prstGeom>
+          <a:solidFill>
+            <a:srgbClr val="1C6EA4"/>
+          </a:solidFill>
+          <a:ln>
+            <a:noFill/>
+          </a:ln>
+          <a:effectLst/>
+        </p:spPr>
+        <p:style>
+          <a:lnRef idx="1">
+            <a:schemeClr val="accent1"/>
+          </a:lnRef>
+          <a:fillRef idx="3">
+            <a:schemeClr val="accent1"/>
+          </a:fillRef>
+          <a:effectRef idx="2">
+            <a:schemeClr val="accent1"/>
+          </a:effectRef>
+          <a:fontRef idx="minor">
+            <a:schemeClr val="lt1"/>
+          </a:fontRef>
+        </p:style>
+        <p:txBody>
+          <a:bodyPr rtlCol="0" anchor="ctr"/>
+          <a:lstStyle/>
+          <a:p>
+            <a:pPr algn="ctr"/>
+          </a:p>
+        </p:txBody>
+      </p:sp>
+      <p:sp>
+        <p:nvSpPr>
+          <p:cNvPr id="5" name="TextBox 4"/>
+          <p:cNvSpPr txBox="1"/>
+          <p:nvPr/>
+        </p:nvSpPr>
+        <p:spPr>
+          <a:xfrm>
+            <a:off x="548640" y="0"/>
+            <a:ext cx="10058400" cy="1051560"/>
+          </a:xfrm>
+          <a:prstGeom prst="rect">
+            <a:avLst/>
+          </a:prstGeom>
+          <a:noFill/>
+        </p:spPr>
+        <p:txBody>
+          <a:bodyPr wrap="square" anchor="ctr">
+            <a:spAutoFit/>
+          </a:bodyPr>
+          <a:lstStyle/>
+          <a:p>
+            <a:pPr algn="l"/>
+            <a:r>
+              <a:rPr sz="2500" b="1" i="0">
+                <a:solidFill>
+                  <a:srgbClr val="FFFFFF"/>
+                </a:solidFill>
+                <a:latin typeface="Calibri"/>
+              </a:rPr>
+              <a:t>Yengil vaznli xesh funksiyalar o'zi nima?</a:t>
+            </a:r>
+          </a:p>
+        </p:txBody>
+      </p:sp>
+      <p:sp>
+        <p:nvSpPr>
+          <p:cNvPr id="6" name="Rectangle 5"/>
+          <p:cNvSpPr/>
+          <p:nvPr/>
+        </p:nvSpPr>
+        <p:spPr>
+          <a:xfrm>
+            <a:off x="11247120" y="292608"/>
+            <a:ext cx="457200" cy="457200"/>
+          </a:xfrm>
+          <a:prstGeom prst="rect">
+            <a:avLst/>
+          </a:prstGeom>
+          <a:solidFill>
+            <a:srgbClr val="1C6EA4"/>
+          </a:solidFill>
+          <a:ln>
+            <a:noFill/>
+          </a:ln>
+          <a:effectLst/>
+        </p:spPr>
+        <p:style>
+          <a:lnRef idx="1">
+            <a:schemeClr val="accent1"/>
+          </a:lnRef>
+          <a:fillRef idx="3">
+            <a:schemeClr val="accent1"/>
+          </a:fillRef>
+          <a:effectRef idx="2">
+            <a:schemeClr val="accent1"/>
+          </a:effectRef>
+          <a:fontRef idx="minor">
+            <a:schemeClr val="lt1"/>
+          </a:fontRef>
+        </p:style>
+        <p:txBody>
+          <a:bodyPr rtlCol="0" anchor="ctr"/>
+          <a:lstStyle/>
+          <a:p>
+            <a:pPr algn="ctr"/>
+          </a:p>
+        </p:txBody>
+      </p:sp>
+      <p:sp>
+        <p:nvSpPr>
+          <p:cNvPr id="7" name="TextBox 6"/>
+          <p:cNvSpPr txBox="1"/>
+          <p:nvPr/>
+        </p:nvSpPr>
+        <p:spPr>
+          <a:xfrm>
+            <a:off x="11247120" y="292608"/>
+            <a:ext cx="457200" cy="457200"/>
+          </a:xfrm>
+          <a:prstGeom prst="rect">
+            <a:avLst/>
+          </a:prstGeom>
+          <a:noFill/>
+        </p:spPr>
+        <p:txBody>
+          <a:bodyPr wrap="square" anchor="ctr">
+            <a:spAutoFit/>
+          </a:bodyPr>
+          <a:lstStyle/>
+          <a:p>
+            <a:pPr algn="ctr"/>
+            <a:r>
+              <a:rPr sz="1600" b="1" i="0">
+                <a:solidFill>
+                  <a:srgbClr val="FFFFFF"/>
+                </a:solidFill>
+                <a:latin typeface="Calibri"/>
+              </a:rPr>
+              <a:t>5</a:t>
+            </a:r>
+          </a:p>
+        </p:txBody>
+      </p:sp>
+      <p:sp>
+        <p:nvSpPr>
+          <p:cNvPr id="8" name="Rectangle 7"/>
+          <p:cNvSpPr/>
+          <p:nvPr/>
+        </p:nvSpPr>
+        <p:spPr>
+          <a:xfrm>
+            <a:off x="731520" y="1280160"/>
+            <a:ext cx="10698480" cy="1005840"/>
+          </a:xfrm>
+          <a:prstGeom prst="rect">
+            <a:avLst/>
+          </a:prstGeom>
+          <a:solidFill>
+            <a:srgbClr val="1C6EA4"/>
+          </a:solidFill>
+          <a:ln>
+            <a:noFill/>
+          </a:ln>
+          <a:effectLst/>
+        </p:spPr>
+        <p:style>
+          <a:lnRef idx="1">
+            <a:schemeClr val="accent1"/>
+          </a:lnRef>
+          <a:fillRef idx="3">
+            <a:schemeClr val="accent1"/>
+          </a:fillRef>
+          <a:effectRef idx="2">
+            <a:schemeClr val="accent1"/>
+          </a:effectRef>
+          <a:fontRef idx="minor">
+            <a:schemeClr val="lt1"/>
+          </a:fontRef>
+        </p:style>
+        <p:txBody>
+          <a:bodyPr rtlCol="0" anchor="ctr"/>
+          <a:lstStyle/>
+          <a:p>
+            <a:pPr algn="ctr"/>
+          </a:p>
+        </p:txBody>
+      </p:sp>
+      <p:sp>
+        <p:nvSpPr>
+          <p:cNvPr id="9" name="TextBox 8"/>
+          <p:cNvSpPr txBox="1"/>
+          <p:nvPr/>
+        </p:nvSpPr>
+        <p:spPr>
+          <a:xfrm>
+            <a:off x="1005840" y="1371600"/>
+            <a:ext cx="10149840" cy="822960"/>
+          </a:xfrm>
+          <a:prstGeom prst="rect">
+            <a:avLst/>
+          </a:prstGeom>
+          <a:noFill/>
+        </p:spPr>
+        <p:txBody>
+          <a:bodyPr wrap="square" anchor="ctr">
+            <a:spAutoFit/>
+          </a:bodyPr>
+          <a:lstStyle/>
+          <a:p>
+            <a:pPr algn="l"/>
+            <a:r>
+              <a:rPr sz="1600" b="1" i="0">
+                <a:solidFill>
+                  <a:srgbClr val="FFFFFF"/>
+                </a:solidFill>
+                <a:latin typeface="Calibri"/>
+              </a:rPr>
+              <a:t>Yengil vaznli (lightweight) xesh funksiyalar — resurslari cheklangan qurilmalar uchun maxsus mo'ljallangan, kam xotira, energiya va hisoblash quvvati talab qiladigan kriptografik xesh funksiyalar.</a:t>
+            </a:r>
+          </a:p>
+        </p:txBody>
+      </p:sp>
+      <p:sp>
+        <p:nvSpPr>
+          <p:cNvPr id="10" name="TextBox 9"/>
+          <p:cNvSpPr txBox="1"/>
+          <p:nvPr/>
+        </p:nvSpPr>
+        <p:spPr>
+          <a:xfrm>
+            <a:off x="731520" y="2514600"/>
+            <a:ext cx="5212080" cy="411480"/>
+          </a:xfrm>
+          <a:prstGeom prst="rect">
+            <a:avLst/>
+          </a:prstGeom>
+          <a:noFill/>
+        </p:spPr>
+        <p:txBody>
+          <a:bodyPr wrap="square" anchor="t">
+            <a:spAutoFit/>
+          </a:bodyPr>
+          <a:lstStyle/>
+          <a:p>
+            <a:pPr algn="l"/>
+            <a:r>
+              <a:rPr sz="1700" b="1" i="0">
+                <a:solidFill>
+                  <a:srgbClr val="0F2C4A"/>
+                </a:solidFill>
+                <a:latin typeface="Calibri"/>
+              </a:rPr>
+              <a:t>Nima uchun kerak?</a:t>
+            </a:r>
+          </a:p>
+        </p:txBody>
+      </p:sp>
+      <p:sp>
+        <p:nvSpPr>
+          <p:cNvPr id="11" name="TextBox 10"/>
+          <p:cNvSpPr txBox="1"/>
+          <p:nvPr/>
+        </p:nvSpPr>
+        <p:spPr>
+          <a:xfrm>
+            <a:off x="731520" y="2971800"/>
+            <a:ext cx="5212080" cy="1828800"/>
+          </a:xfrm>
+          <a:prstGeom prst="rect">
+            <a:avLst/>
+          </a:prstGeom>
+          <a:noFill/>
+        </p:spPr>
+        <p:txBody>
+          <a:bodyPr wrap="square">
+            <a:spAutoFit/>
+          </a:bodyPr>
+          <a:lstStyle/>
+          <a:p>
+            <a:pPr algn="l">
+              <a:spcAft>
+                <a:spcPts val="1000"/>
+              </a:spcAft>
+            </a:pPr>
+            <a:r>
+              <a:rPr sz="1400" b="1">
+                <a:solidFill>
+                  <a:srgbClr val="1C6EA4"/>
+                </a:solidFill>
+                <a:latin typeface="Calibri"/>
+              </a:rPr>
+              <a:t>▸  </a:t>
+            </a:r>
+            <a:r>
+              <a:rPr sz="1400">
+                <a:solidFill>
+                  <a:srgbClr val="444A52"/>
+                </a:solidFill>
+                <a:latin typeface="Calibri"/>
+              </a:rPr>
+              <a:t>An'anaviy xesh (SHA-256) IoT qurilmalari uchun og'ir;</a:t>
+            </a:r>
+          </a:p>
+          <a:p>
+            <a:pPr algn="l">
+              <a:spcAft>
+                <a:spcPts val="1000"/>
+              </a:spcAft>
+            </a:pPr>
+            <a:r>
+              <a:rPr sz="1400" b="1">
+                <a:solidFill>
+                  <a:srgbClr val="1C6EA4"/>
+                </a:solidFill>
+                <a:latin typeface="Calibri"/>
+              </a:rPr>
+              <a:t>▸  </a:t>
+            </a:r>
+            <a:r>
+              <a:rPr sz="1400">
+                <a:solidFill>
+                  <a:srgbClr val="444A52"/>
+                </a:solidFill>
+                <a:latin typeface="Calibri"/>
+              </a:rPr>
+              <a:t>Kichik sensor, RFID teg, smart-karta kam quvvatga ega;</a:t>
+            </a:r>
+          </a:p>
+          <a:p>
+            <a:pPr algn="l">
+              <a:spcAft>
+                <a:spcPts val="1000"/>
+              </a:spcAft>
+            </a:pPr>
+            <a:r>
+              <a:rPr sz="1400" b="1">
+                <a:solidFill>
+                  <a:srgbClr val="1C6EA4"/>
+                </a:solidFill>
+                <a:latin typeface="Calibri"/>
+              </a:rPr>
+              <a:t>▸  </a:t>
+            </a:r>
+            <a:r>
+              <a:rPr sz="1400">
+                <a:solidFill>
+                  <a:srgbClr val="444A52"/>
+                </a:solidFill>
+                <a:latin typeface="Calibri"/>
+              </a:rPr>
+              <a:t>Kam joy (gate) va energiya bilan xavfsizlik kerak.</a:t>
+            </a:r>
+          </a:p>
+        </p:txBody>
+      </p:sp>
+      <p:sp>
+        <p:nvSpPr>
+          <p:cNvPr id="12" name="TextBox 11"/>
+          <p:cNvSpPr txBox="1"/>
+          <p:nvPr/>
+        </p:nvSpPr>
+        <p:spPr>
+          <a:xfrm>
+            <a:off x="731520" y="4800600"/>
+            <a:ext cx="5212080" cy="411480"/>
+          </a:xfrm>
+          <a:prstGeom prst="rect">
+            <a:avLst/>
+          </a:prstGeom>
+          <a:noFill/>
+        </p:spPr>
+        <p:txBody>
+          <a:bodyPr wrap="square" anchor="t">
+            <a:spAutoFit/>
+          </a:bodyPr>
+          <a:lstStyle/>
+          <a:p>
+            <a:pPr algn="l"/>
+            <a:r>
+              <a:rPr sz="1700" b="1" i="0">
+                <a:solidFill>
+                  <a:srgbClr val="0F2C4A"/>
+                </a:solidFill>
+                <a:latin typeface="Calibri"/>
+              </a:rPr>
+              <a:t>Qayerda ishlatiladi?</a:t>
+            </a:r>
+          </a:p>
+        </p:txBody>
+      </p:sp>
+      <p:sp>
+        <p:nvSpPr>
+          <p:cNvPr id="13" name="Rectangle 12"/>
+          <p:cNvSpPr/>
+          <p:nvPr/>
+        </p:nvSpPr>
+        <p:spPr>
+          <a:xfrm>
+            <a:off x="731520" y="5303520"/>
+            <a:ext cx="1207008" cy="914400"/>
+          </a:xfrm>
+          <a:prstGeom prst="rect">
+            <a:avLst/>
+          </a:prstGeom>
+          <a:solidFill>
+            <a:srgbClr val="E8F1F8"/>
+          </a:solidFill>
+          <a:ln>
+            <a:noFill/>
+          </a:ln>
+          <a:effectLst/>
+        </p:spPr>
+        <p:style>
+          <a:lnRef idx="1">
+            <a:schemeClr val="accent1"/>
+          </a:lnRef>
+          <a:fillRef idx="3">
+            <a:schemeClr val="accent1"/>
+          </a:fillRef>
+          <a:effectRef idx="2">
+            <a:schemeClr val="accent1"/>
+          </a:effectRef>
+          <a:fontRef idx="minor">
+            <a:schemeClr val="lt1"/>
+          </a:fontRef>
+        </p:style>
+        <p:txBody>
+          <a:bodyPr rtlCol="0" anchor="ctr"/>
+          <a:lstStyle/>
+          <a:p>
+            <a:pPr algn="ctr"/>
+          </a:p>
+        </p:txBody>
+      </p:sp>
+      <p:sp>
+        <p:nvSpPr>
+          <p:cNvPr id="14" name="Rectangle 13"/>
+          <p:cNvSpPr/>
+          <p:nvPr/>
+        </p:nvSpPr>
+        <p:spPr>
+          <a:xfrm>
+            <a:off x="731520" y="5303520"/>
+            <a:ext cx="1207008" cy="73152"/>
+          </a:xfrm>
+          <a:prstGeom prst="rect">
+            <a:avLst/>
+          </a:prstGeom>
+          <a:solidFill>
+            <a:srgbClr val="1C6EA4"/>
+          </a:solidFill>
+          <a:ln>
+            <a:noFill/>
+          </a:ln>
+          <a:effectLst/>
+        </p:spPr>
+        <p:style>
+          <a:lnRef idx="1">
+            <a:schemeClr val="accent1"/>
+          </a:lnRef>
+          <a:fillRef idx="3">
+            <a:schemeClr val="accent1"/>
+          </a:fillRef>
+          <a:effectRef idx="2">
+            <a:schemeClr val="accent1"/>
+          </a:effectRef>
+          <a:fontRef idx="minor">
+            <a:schemeClr val="lt1"/>
+          </a:fontRef>
+        </p:style>
+        <p:txBody>
+          <a:bodyPr rtlCol="0" anchor="ctr"/>
+          <a:lstStyle/>
+          <a:p>
+            <a:pPr algn="ctr"/>
+          </a:p>
+        </p:txBody>
+      </p:sp>
+      <p:sp>
+        <p:nvSpPr>
+          <p:cNvPr id="15" name="TextBox 14"/>
+          <p:cNvSpPr txBox="1"/>
+          <p:nvPr/>
+        </p:nvSpPr>
+        <p:spPr>
+          <a:xfrm>
+            <a:off x="731520" y="5376672"/>
+            <a:ext cx="1207008" cy="822960"/>
+          </a:xfrm>
+          <a:prstGeom prst="rect">
+            <a:avLst/>
+          </a:prstGeom>
+          <a:noFill/>
+        </p:spPr>
+        <p:txBody>
+          <a:bodyPr wrap="square" anchor="ctr">
+            <a:spAutoFit/>
+          </a:bodyPr>
+          <a:lstStyle/>
+          <a:p>
+            <a:pPr algn="ctr"/>
+            <a:r>
+              <a:rPr sz="1200" b="1" i="0">
+                <a:solidFill>
+                  <a:srgbClr val="0F2C4A"/>
+                </a:solidFill>
+                <a:latin typeface="Calibri"/>
+              </a:rPr>
+              <a:t>IoT</a:t>
+            </a:r>
+          </a:p>
+          <a:p>
+            <a:pPr algn="ctr"/>
+            <a:r>
+              <a:rPr sz="1200" b="1" i="0">
+                <a:solidFill>
+                  <a:srgbClr val="0F2C4A"/>
+                </a:solidFill>
+                <a:latin typeface="Calibri"/>
+              </a:rPr>
+              <a:t>qurilmalar</a:t>
+            </a:r>
+          </a:p>
+        </p:txBody>
+      </p:sp>
+      <p:sp>
+        <p:nvSpPr>
+          <p:cNvPr id="16" name="Rectangle 15"/>
+          <p:cNvSpPr/>
+          <p:nvPr/>
+        </p:nvSpPr>
+        <p:spPr>
+          <a:xfrm>
+            <a:off x="2057400" y="5303520"/>
+            <a:ext cx="1207008" cy="914400"/>
+          </a:xfrm>
+          <a:prstGeom prst="rect">
+            <a:avLst/>
+          </a:prstGeom>
+          <a:solidFill>
+            <a:srgbClr val="E8F1F8"/>
+          </a:solidFill>
+          <a:ln>
+            <a:noFill/>
+          </a:ln>
+          <a:effectLst/>
+        </p:spPr>
+        <p:style>
+          <a:lnRef idx="1">
+            <a:schemeClr val="accent1"/>
+          </a:lnRef>
+          <a:fillRef idx="3">
+            <a:schemeClr val="accent1"/>
+          </a:fillRef>
+          <a:effectRef idx="2">
+            <a:schemeClr val="accent1"/>
+          </a:effectRef>
+          <a:fontRef idx="minor">
+            <a:schemeClr val="lt1"/>
+          </a:fontRef>
+        </p:style>
+        <p:txBody>
+          <a:bodyPr rtlCol="0" anchor="ctr"/>
+          <a:lstStyle/>
+          <a:p>
+            <a:pPr algn="ctr"/>
+          </a:p>
+        </p:txBody>
+      </p:sp>
+      <p:sp>
+        <p:nvSpPr>
+          <p:cNvPr id="17" name="Rectangle 16"/>
+          <p:cNvSpPr/>
+          <p:nvPr/>
+        </p:nvSpPr>
+        <p:spPr>
+          <a:xfrm>
+            <a:off x="2057400" y="5303520"/>
+            <a:ext cx="1207008" cy="73152"/>
+          </a:xfrm>
+          <a:prstGeom prst="rect">
+            <a:avLst/>
+          </a:prstGeom>
+          <a:solidFill>
+            <a:srgbClr val="1C6EA4"/>
+          </a:solidFill>
+          <a:ln>
+            <a:noFill/>
+          </a:ln>
+          <a:effectLst/>
+        </p:spPr>
+        <p:style>
+          <a:lnRef idx="1">
+            <a:schemeClr val="accent1"/>
+          </a:lnRef>
+          <a:fillRef idx="3">
+            <a:schemeClr val="accent1"/>
+          </a:fillRef>
+          <a:effectRef idx="2">
+            <a:schemeClr val="accent1"/>
+          </a:effectRef>
+          <a:fontRef idx="minor">
+            <a:schemeClr val="lt1"/>
+          </a:fontRef>
+        </p:style>
+        <p:txBody>
+          <a:bodyPr rtlCol="0" anchor="ctr"/>
+          <a:lstStyle/>
+          <a:p>
+            <a:pPr algn="ctr"/>
+          </a:p>
+        </p:txBody>
+      </p:sp>
+      <p:sp>
+        <p:nvSpPr>
+          <p:cNvPr id="18" name="TextBox 17"/>
+          <p:cNvSpPr txBox="1"/>
+          <p:nvPr/>
+        </p:nvSpPr>
+        <p:spPr>
+          <a:xfrm>
+            <a:off x="2057400" y="5376672"/>
+            <a:ext cx="1207008" cy="822960"/>
+          </a:xfrm>
+          <a:prstGeom prst="rect">
+            <a:avLst/>
+          </a:prstGeom>
+          <a:noFill/>
+        </p:spPr>
+        <p:txBody>
+          <a:bodyPr wrap="square" anchor="ctr">
+            <a:spAutoFit/>
+          </a:bodyPr>
+          <a:lstStyle/>
+          <a:p>
+            <a:pPr algn="ctr"/>
+            <a:r>
+              <a:rPr sz="1200" b="1" i="0">
+                <a:solidFill>
+                  <a:srgbClr val="0F2C4A"/>
+                </a:solidFill>
+                <a:latin typeface="Calibri"/>
+              </a:rPr>
+              <a:t>RFID</a:t>
+            </a:r>
+          </a:p>
+          <a:p>
+            <a:pPr algn="ctr"/>
+            <a:r>
+              <a:rPr sz="1200" b="1" i="0">
+                <a:solidFill>
+                  <a:srgbClr val="0F2C4A"/>
+                </a:solidFill>
+                <a:latin typeface="Calibri"/>
+              </a:rPr>
+              <a:t>teglar</a:t>
+            </a:r>
+          </a:p>
+        </p:txBody>
+      </p:sp>
+      <p:sp>
+        <p:nvSpPr>
+          <p:cNvPr id="19" name="Rectangle 18"/>
+          <p:cNvSpPr/>
+          <p:nvPr/>
+        </p:nvSpPr>
+        <p:spPr>
+          <a:xfrm>
+            <a:off x="3383280" y="5303520"/>
+            <a:ext cx="1207008" cy="914400"/>
+          </a:xfrm>
+          <a:prstGeom prst="rect">
+            <a:avLst/>
+          </a:prstGeom>
+          <a:solidFill>
+            <a:srgbClr val="E8F1F8"/>
+          </a:solidFill>
+          <a:ln>
+            <a:noFill/>
+          </a:ln>
+          <a:effectLst/>
+        </p:spPr>
+        <p:style>
+          <a:lnRef idx="1">
+            <a:schemeClr val="accent1"/>
+          </a:lnRef>
+          <a:fillRef idx="3">
+            <a:schemeClr val="accent1"/>
+          </a:fillRef>
+          <a:effectRef idx="2">
+            <a:schemeClr val="accent1"/>
+          </a:effectRef>
+          <a:fontRef idx="minor">
+            <a:schemeClr val="lt1"/>
+          </a:fontRef>
+        </p:style>
+        <p:txBody>
+          <a:bodyPr rtlCol="0" anchor="ctr"/>
+          <a:lstStyle/>
+          <a:p>
+            <a:pPr algn="ctr"/>
+          </a:p>
+        </p:txBody>
+      </p:sp>
+      <p:sp>
+        <p:nvSpPr>
+          <p:cNvPr id="20" name="Rectangle 19"/>
+          <p:cNvSpPr/>
+          <p:nvPr/>
+        </p:nvSpPr>
+        <p:spPr>
+          <a:xfrm>
+            <a:off x="3383280" y="5303520"/>
+            <a:ext cx="1207008" cy="73152"/>
+          </a:xfrm>
+          <a:prstGeom prst="rect">
+            <a:avLst/>
+          </a:prstGeom>
+          <a:solidFill>
+            <a:srgbClr val="1C6EA4"/>
+          </a:solidFill>
+          <a:ln>
+            <a:noFill/>
+          </a:ln>
+          <a:effectLst/>
+        </p:spPr>
+        <p:style>
+          <a:lnRef idx="1">
+            <a:schemeClr val="accent1"/>
+          </a:lnRef>
+          <a:fillRef idx="3">
+            <a:schemeClr val="accent1"/>
+          </a:fillRef>
+          <a:effectRef idx="2">
+            <a:schemeClr val="accent1"/>
+          </a:effectRef>
+          <a:fontRef idx="minor">
+            <a:schemeClr val="lt1"/>
+          </a:fontRef>
+        </p:style>
+        <p:txBody>
+          <a:bodyPr rtlCol="0" anchor="ctr"/>
+          <a:lstStyle/>
+          <a:p>
+            <a:pPr algn="ctr"/>
+          </a:p>
+        </p:txBody>
+      </p:sp>
+      <p:sp>
+        <p:nvSpPr>
+          <p:cNvPr id="21" name="TextBox 20"/>
+          <p:cNvSpPr txBox="1"/>
+          <p:nvPr/>
+        </p:nvSpPr>
+        <p:spPr>
+          <a:xfrm>
+            <a:off x="3383280" y="5376672"/>
+            <a:ext cx="1207008" cy="822960"/>
+          </a:xfrm>
+          <a:prstGeom prst="rect">
+            <a:avLst/>
+          </a:prstGeom>
+          <a:noFill/>
+        </p:spPr>
+        <p:txBody>
+          <a:bodyPr wrap="square" anchor="ctr">
+            <a:spAutoFit/>
+          </a:bodyPr>
+          <a:lstStyle/>
+          <a:p>
+            <a:pPr algn="ctr"/>
+            <a:r>
+              <a:rPr sz="1200" b="1" i="0">
+                <a:solidFill>
+                  <a:srgbClr val="0F2C4A"/>
+                </a:solidFill>
+                <a:latin typeface="Calibri"/>
+              </a:rPr>
+              <a:t>Sensor</a:t>
+            </a:r>
+          </a:p>
+          <a:p>
+            <a:pPr algn="ctr"/>
+            <a:r>
+              <a:rPr sz="1200" b="1" i="0">
+                <a:solidFill>
+                  <a:srgbClr val="0F2C4A"/>
+                </a:solidFill>
+                <a:latin typeface="Calibri"/>
+              </a:rPr>
+              <a:t>tarmoqlar</a:t>
+            </a:r>
+          </a:p>
+        </p:txBody>
+      </p:sp>
+      <p:sp>
+        <p:nvSpPr>
+          <p:cNvPr id="22" name="Rectangle 21"/>
+          <p:cNvSpPr/>
+          <p:nvPr/>
+        </p:nvSpPr>
+        <p:spPr>
+          <a:xfrm>
+            <a:off x="4709160" y="5303520"/>
+            <a:ext cx="1207008" cy="914400"/>
+          </a:xfrm>
+          <a:prstGeom prst="rect">
+            <a:avLst/>
+          </a:prstGeom>
+          <a:solidFill>
+            <a:srgbClr val="E8F1F8"/>
+          </a:solidFill>
+          <a:ln>
+            <a:noFill/>
+          </a:ln>
+          <a:effectLst/>
+        </p:spPr>
+        <p:style>
+          <a:lnRef idx="1">
+            <a:schemeClr val="accent1"/>
+          </a:lnRef>
+          <a:fillRef idx="3">
+            <a:schemeClr val="accent1"/>
+          </a:fillRef>
+          <a:effectRef idx="2">
+            <a:schemeClr val="accent1"/>
+          </a:effectRef>
+          <a:fontRef idx="minor">
+            <a:schemeClr val="lt1"/>
+          </a:fontRef>
+        </p:style>
+        <p:txBody>
+          <a:bodyPr rtlCol="0" anchor="ctr"/>
+          <a:lstStyle/>
+          <a:p>
+            <a:pPr algn="ctr"/>
+          </a:p>
+        </p:txBody>
+      </p:sp>
+      <p:sp>
+        <p:nvSpPr>
+          <p:cNvPr id="23" name="Rectangle 22"/>
+          <p:cNvSpPr/>
+          <p:nvPr/>
+        </p:nvSpPr>
+        <p:spPr>
+          <a:xfrm>
+            <a:off x="4709160" y="5303520"/>
+            <a:ext cx="1207008" cy="73152"/>
+          </a:xfrm>
+          <a:prstGeom prst="rect">
+            <a:avLst/>
+          </a:prstGeom>
+          <a:solidFill>
+            <a:srgbClr val="1C6EA4"/>
+          </a:solidFill>
+          <a:ln>
+            <a:noFill/>
+          </a:ln>
+          <a:effectLst/>
+        </p:spPr>
+        <p:style>
+          <a:lnRef idx="1">
+            <a:schemeClr val="accent1"/>
+          </a:lnRef>
+          <a:fillRef idx="3">
+            <a:schemeClr val="accent1"/>
+          </a:fillRef>
+          <a:effectRef idx="2">
+            <a:schemeClr val="accent1"/>
+          </a:effectRef>
+          <a:fontRef idx="minor">
+            <a:schemeClr val="lt1"/>
+          </a:fontRef>
+        </p:style>
+        <p:txBody>
+          <a:bodyPr rtlCol="0" anchor="ctr"/>
+          <a:lstStyle/>
+          <a:p>
+            <a:pPr algn="ctr"/>
+          </a:p>
+        </p:txBody>
+      </p:sp>
+      <p:sp>
+        <p:nvSpPr>
+          <p:cNvPr id="24" name="TextBox 23"/>
+          <p:cNvSpPr txBox="1"/>
+          <p:nvPr/>
+        </p:nvSpPr>
+        <p:spPr>
+          <a:xfrm>
+            <a:off x="4709160" y="5376672"/>
+            <a:ext cx="1207008" cy="822960"/>
+          </a:xfrm>
+          <a:prstGeom prst="rect">
+            <a:avLst/>
+          </a:prstGeom>
+          <a:noFill/>
+        </p:spPr>
+        <p:txBody>
+          <a:bodyPr wrap="square" anchor="ctr">
+            <a:spAutoFit/>
+          </a:bodyPr>
+          <a:lstStyle/>
+          <a:p>
+            <a:pPr algn="ctr"/>
+            <a:r>
+              <a:rPr sz="1200" b="1" i="0">
+                <a:solidFill>
+                  <a:srgbClr val="0F2C4A"/>
+                </a:solidFill>
+                <a:latin typeface="Calibri"/>
+              </a:rPr>
+              <a:t>Smart</a:t>
+            </a:r>
+          </a:p>
+          <a:p>
+            <a:pPr algn="ctr"/>
+            <a:r>
+              <a:rPr sz="1200" b="1" i="0">
+                <a:solidFill>
+                  <a:srgbClr val="0F2C4A"/>
+                </a:solidFill>
+                <a:latin typeface="Calibri"/>
+              </a:rPr>
+              <a:t>kartalar</a:t>
+            </a:r>
+          </a:p>
+        </p:txBody>
+      </p:sp>
+      <p:sp>
+        <p:nvSpPr>
+          <p:cNvPr id="25" name="Rectangle 24"/>
+          <p:cNvSpPr/>
+          <p:nvPr/>
+        </p:nvSpPr>
+        <p:spPr>
+          <a:xfrm>
+            <a:off x="6355080" y="2514600"/>
+            <a:ext cx="5074920" cy="3703320"/>
+          </a:xfrm>
+          <a:prstGeom prst="rect">
+            <a:avLst/>
+          </a:prstGeom>
+          <a:solidFill>
+            <a:srgbClr val="E8F1F8"/>
+          </a:solidFill>
+          <a:ln>
+            <a:noFill/>
+          </a:ln>
+          <a:effectLst/>
+        </p:spPr>
+        <p:style>
+          <a:lnRef idx="1">
+            <a:schemeClr val="accent1"/>
+          </a:lnRef>
+          <a:fillRef idx="3">
+            <a:schemeClr val="accent1"/>
+          </a:fillRef>
+          <a:effectRef idx="2">
+            <a:schemeClr val="accent1"/>
+          </a:effectRef>
+          <a:fontRef idx="minor">
+            <a:schemeClr val="lt1"/>
+          </a:fontRef>
+        </p:style>
+        <p:txBody>
+          <a:bodyPr rtlCol="0" anchor="ctr"/>
+          <a:lstStyle/>
+          <a:p>
+            <a:pPr algn="ctr"/>
+          </a:p>
+        </p:txBody>
+      </p:sp>
+      <p:sp>
+        <p:nvSpPr>
+          <p:cNvPr id="26" name="TextBox 25"/>
+          <p:cNvSpPr txBox="1"/>
+          <p:nvPr/>
+        </p:nvSpPr>
+        <p:spPr>
+          <a:xfrm>
+            <a:off x="6537960" y="2651760"/>
+            <a:ext cx="4754880" cy="411480"/>
+          </a:xfrm>
+          <a:prstGeom prst="rect">
+            <a:avLst/>
+          </a:prstGeom>
+          <a:noFill/>
+        </p:spPr>
+        <p:txBody>
+          <a:bodyPr wrap="square" anchor="t">
+            <a:spAutoFit/>
+          </a:bodyPr>
+          <a:lstStyle/>
+          <a:p>
+            <a:pPr algn="l"/>
+            <a:r>
+              <a:rPr sz="1700" b="1" i="0">
+                <a:solidFill>
+                  <a:srgbClr val="0F2C4A"/>
+                </a:solidFill>
+                <a:latin typeface="Calibri"/>
+              </a:rPr>
+              <a:t>An'anaviy vs Yengil vaznli</a:t>
+            </a:r>
+          </a:p>
+        </p:txBody>
+      </p:sp>
+      <p:sp>
+        <p:nvSpPr>
+          <p:cNvPr id="27" name="TextBox 26"/>
+          <p:cNvSpPr txBox="1"/>
+          <p:nvPr/>
+        </p:nvSpPr>
+        <p:spPr>
+          <a:xfrm>
+            <a:off x="6537960" y="3154680"/>
+            <a:ext cx="1828800" cy="457200"/>
+          </a:xfrm>
+          <a:prstGeom prst="rect">
+            <a:avLst/>
+          </a:prstGeom>
+          <a:noFill/>
+        </p:spPr>
+        <p:txBody>
+          <a:bodyPr wrap="square" anchor="ctr">
+            <a:spAutoFit/>
+          </a:bodyPr>
+          <a:lstStyle/>
+          <a:p>
+            <a:pPr algn="l"/>
+            <a:r>
+              <a:rPr sz="1300" b="1" i="0">
+                <a:solidFill>
+                  <a:srgbClr val="0F2C4A"/>
+                </a:solidFill>
+                <a:latin typeface="Calibri"/>
+              </a:rPr>
+              <a:t>Mezon</a:t>
+            </a:r>
+          </a:p>
+        </p:txBody>
+      </p:sp>
+      <p:sp>
+        <p:nvSpPr>
+          <p:cNvPr id="28" name="TextBox 27"/>
+          <p:cNvSpPr txBox="1"/>
+          <p:nvPr/>
+        </p:nvSpPr>
+        <p:spPr>
+          <a:xfrm>
+            <a:off x="8366760" y="3154680"/>
+            <a:ext cx="1554480" cy="457200"/>
+          </a:xfrm>
+          <a:prstGeom prst="rect">
+            <a:avLst/>
+          </a:prstGeom>
+          <a:noFill/>
+        </p:spPr>
+        <p:txBody>
+          <a:bodyPr wrap="square" anchor="ctr">
+            <a:spAutoFit/>
+          </a:bodyPr>
+          <a:lstStyle/>
+          <a:p>
+            <a:pPr algn="l"/>
+            <a:r>
+              <a:rPr sz="1300" b="1" i="0">
+                <a:solidFill>
+                  <a:srgbClr val="0F2C4A"/>
+                </a:solidFill>
+                <a:latin typeface="Calibri"/>
+              </a:rPr>
+              <a:t>An'anaviy</a:t>
+            </a:r>
+          </a:p>
+        </p:txBody>
+      </p:sp>
+      <p:sp>
+        <p:nvSpPr>
+          <p:cNvPr id="29" name="TextBox 28"/>
+          <p:cNvSpPr txBox="1"/>
+          <p:nvPr/>
+        </p:nvSpPr>
+        <p:spPr>
+          <a:xfrm>
+            <a:off x="9921240" y="3154680"/>
+            <a:ext cx="1463040" cy="457200"/>
+          </a:xfrm>
+          <a:prstGeom prst="rect">
+            <a:avLst/>
+          </a:prstGeom>
+          <a:noFill/>
+        </p:spPr>
+        <p:txBody>
+          <a:bodyPr wrap="square" anchor="ctr">
+            <a:spAutoFit/>
+          </a:bodyPr>
+          <a:lstStyle/>
+          <a:p>
+            <a:pPr algn="l"/>
+            <a:r>
+              <a:rPr sz="1300" b="1" i="0">
+                <a:solidFill>
+                  <a:srgbClr val="0F2C4A"/>
+                </a:solidFill>
+                <a:latin typeface="Calibri"/>
+              </a:rPr>
+              <a:t>Yengil vaznli</a:t>
+            </a:r>
+          </a:p>
+        </p:txBody>
+      </p:sp>
+      <p:sp>
+        <p:nvSpPr>
+          <p:cNvPr id="30" name="Rectangle 29"/>
+          <p:cNvSpPr/>
+          <p:nvPr/>
+        </p:nvSpPr>
+        <p:spPr>
+          <a:xfrm>
+            <a:off x="6537960" y="3611880"/>
+            <a:ext cx="4754880" cy="19050"/>
+          </a:xfrm>
+          <a:prstGeom prst="rect">
+            <a:avLst/>
+          </a:prstGeom>
+          <a:solidFill>
+            <a:srgbClr val="1C6EA4"/>
+          </a:solidFill>
+          <a:ln>
+            <a:noFill/>
+          </a:ln>
+          <a:effectLst/>
+        </p:spPr>
+        <p:style>
+          <a:lnRef idx="1">
+            <a:schemeClr val="accent1"/>
+          </a:lnRef>
+          <a:fillRef idx="3">
+            <a:schemeClr val="accent1"/>
+          </a:fillRef>
+          <a:effectRef idx="2">
+            <a:schemeClr val="accent1"/>
+          </a:effectRef>
+          <a:fontRef idx="minor">
+            <a:schemeClr val="lt1"/>
+          </a:fontRef>
+        </p:style>
+        <p:txBody>
+          <a:bodyPr rtlCol="0" anchor="ctr"/>
+          <a:lstStyle/>
+          <a:p>
+            <a:pPr algn="ctr"/>
+          </a:p>
+        </p:txBody>
+      </p:sp>
+      <p:sp>
+        <p:nvSpPr>
+          <p:cNvPr id="31" name="TextBox 30"/>
+          <p:cNvSpPr txBox="1"/>
+          <p:nvPr/>
+        </p:nvSpPr>
+        <p:spPr>
+          <a:xfrm>
+            <a:off x="6537960" y="3721608"/>
+            <a:ext cx="1828800" cy="457200"/>
+          </a:xfrm>
+          <a:prstGeom prst="rect">
+            <a:avLst/>
+          </a:prstGeom>
+          <a:noFill/>
+        </p:spPr>
+        <p:txBody>
+          <a:bodyPr wrap="square" anchor="ctr">
+            <a:spAutoFit/>
+          </a:bodyPr>
+          <a:lstStyle/>
+          <a:p>
+            <a:pPr algn="l"/>
+            <a:r>
+              <a:rPr sz="1300" b="1" i="0">
+                <a:solidFill>
+                  <a:srgbClr val="444A52"/>
+                </a:solidFill>
+                <a:latin typeface="Calibri"/>
+              </a:rPr>
+              <a:t>Resurs (GE)</a:t>
+            </a:r>
+          </a:p>
+        </p:txBody>
+      </p:sp>
+      <p:sp>
+        <p:nvSpPr>
+          <p:cNvPr id="32" name="TextBox 31"/>
+          <p:cNvSpPr txBox="1"/>
+          <p:nvPr/>
+        </p:nvSpPr>
+        <p:spPr>
+          <a:xfrm>
+            <a:off x="8366760" y="3721608"/>
+            <a:ext cx="1554480" cy="457200"/>
+          </a:xfrm>
+          <a:prstGeom prst="rect">
+            <a:avLst/>
+          </a:prstGeom>
+          <a:noFill/>
+        </p:spPr>
+        <p:txBody>
+          <a:bodyPr wrap="square" anchor="ctr">
+            <a:spAutoFit/>
+          </a:bodyPr>
+          <a:lstStyle/>
+          <a:p>
+            <a:pPr algn="l"/>
+            <a:r>
+              <a:rPr sz="1300" b="0" i="0">
+                <a:solidFill>
+                  <a:srgbClr val="444A52"/>
+                </a:solidFill>
+                <a:latin typeface="Calibri"/>
+              </a:rPr>
+              <a:t>10 000+</a:t>
+            </a:r>
+          </a:p>
+        </p:txBody>
+      </p:sp>
+      <p:sp>
+        <p:nvSpPr>
+          <p:cNvPr id="33" name="TextBox 32"/>
+          <p:cNvSpPr txBox="1"/>
+          <p:nvPr/>
+        </p:nvSpPr>
+        <p:spPr>
+          <a:xfrm>
+            <a:off x="9921240" y="3721608"/>
+            <a:ext cx="1463040" cy="457200"/>
+          </a:xfrm>
+          <a:prstGeom prst="rect">
+            <a:avLst/>
+          </a:prstGeom>
+          <a:noFill/>
+        </p:spPr>
+        <p:txBody>
+          <a:bodyPr wrap="square" anchor="ctr">
+            <a:spAutoFit/>
+          </a:bodyPr>
+          <a:lstStyle/>
+          <a:p>
+            <a:pPr algn="l"/>
+            <a:r>
+              <a:rPr sz="1300" b="1" i="0">
+                <a:solidFill>
+                  <a:srgbClr val="1E8E5A"/>
+                </a:solidFill>
+                <a:latin typeface="Calibri"/>
+              </a:rPr>
+              <a:t>1 300–3 700</a:t>
+            </a:r>
+          </a:p>
+        </p:txBody>
+      </p:sp>
+      <p:sp>
+        <p:nvSpPr>
+          <p:cNvPr id="34" name="TextBox 33"/>
+          <p:cNvSpPr txBox="1"/>
+          <p:nvPr/>
+        </p:nvSpPr>
+        <p:spPr>
+          <a:xfrm>
+            <a:off x="6537960" y="4288536"/>
+            <a:ext cx="1828800" cy="457200"/>
+          </a:xfrm>
+          <a:prstGeom prst="rect">
+            <a:avLst/>
+          </a:prstGeom>
+          <a:noFill/>
+        </p:spPr>
+        <p:txBody>
+          <a:bodyPr wrap="square" anchor="ctr">
+            <a:spAutoFit/>
+          </a:bodyPr>
+          <a:lstStyle/>
+          <a:p>
+            <a:pPr algn="l"/>
+            <a:r>
+              <a:rPr sz="1300" b="1" i="0">
+                <a:solidFill>
+                  <a:srgbClr val="444A52"/>
+                </a:solidFill>
+                <a:latin typeface="Calibri"/>
+              </a:rPr>
+              <a:t>Energiya</a:t>
+            </a:r>
+          </a:p>
+        </p:txBody>
+      </p:sp>
+      <p:sp>
+        <p:nvSpPr>
+          <p:cNvPr id="35" name="TextBox 34"/>
+          <p:cNvSpPr txBox="1"/>
+          <p:nvPr/>
+        </p:nvSpPr>
+        <p:spPr>
+          <a:xfrm>
+            <a:off x="8366760" y="4288536"/>
+            <a:ext cx="1554480" cy="457200"/>
+          </a:xfrm>
+          <a:prstGeom prst="rect">
+            <a:avLst/>
+          </a:prstGeom>
+          <a:noFill/>
+        </p:spPr>
+        <p:txBody>
+          <a:bodyPr wrap="square" anchor="ctr">
+            <a:spAutoFit/>
+          </a:bodyPr>
+          <a:lstStyle/>
+          <a:p>
+            <a:pPr algn="l"/>
+            <a:r>
+              <a:rPr sz="1300" b="0" i="0">
+                <a:solidFill>
+                  <a:srgbClr val="444A52"/>
+                </a:solidFill>
+                <a:latin typeface="Calibri"/>
+              </a:rPr>
+              <a:t>Yuqori</a:t>
+            </a:r>
+          </a:p>
+        </p:txBody>
+      </p:sp>
+      <p:sp>
+        <p:nvSpPr>
+          <p:cNvPr id="36" name="TextBox 35"/>
+          <p:cNvSpPr txBox="1"/>
+          <p:nvPr/>
+        </p:nvSpPr>
+        <p:spPr>
+          <a:xfrm>
+            <a:off x="9921240" y="4288536"/>
+            <a:ext cx="1463040" cy="457200"/>
+          </a:xfrm>
+          <a:prstGeom prst="rect">
+            <a:avLst/>
+          </a:prstGeom>
+          <a:noFill/>
+        </p:spPr>
+        <p:txBody>
+          <a:bodyPr wrap="square" anchor="ctr">
+            <a:spAutoFit/>
+          </a:bodyPr>
+          <a:lstStyle/>
+          <a:p>
+            <a:pPr algn="l"/>
+            <a:r>
+              <a:rPr sz="1300" b="1" i="0">
+                <a:solidFill>
+                  <a:srgbClr val="1E8E5A"/>
+                </a:solidFill>
+                <a:latin typeface="Calibri"/>
+              </a:rPr>
+              <a:t>Past</a:t>
+            </a:r>
+          </a:p>
+        </p:txBody>
+      </p:sp>
+      <p:sp>
+        <p:nvSpPr>
+          <p:cNvPr id="37" name="TextBox 36"/>
+          <p:cNvSpPr txBox="1"/>
+          <p:nvPr/>
+        </p:nvSpPr>
+        <p:spPr>
+          <a:xfrm>
+            <a:off x="6537960" y="4855464"/>
+            <a:ext cx="1828800" cy="457200"/>
+          </a:xfrm>
+          <a:prstGeom prst="rect">
+            <a:avLst/>
+          </a:prstGeom>
+          <a:noFill/>
+        </p:spPr>
+        <p:txBody>
+          <a:bodyPr wrap="square" anchor="ctr">
+            <a:spAutoFit/>
+          </a:bodyPr>
+          <a:lstStyle/>
+          <a:p>
+            <a:pPr algn="l"/>
+            <a:r>
+              <a:rPr sz="1300" b="1" i="0">
+                <a:solidFill>
+                  <a:srgbClr val="444A52"/>
+                </a:solidFill>
+                <a:latin typeface="Calibri"/>
+              </a:rPr>
+              <a:t>Tezlik</a:t>
+            </a:r>
+          </a:p>
+        </p:txBody>
+      </p:sp>
+      <p:sp>
+        <p:nvSpPr>
+          <p:cNvPr id="38" name="TextBox 37"/>
+          <p:cNvSpPr txBox="1"/>
+          <p:nvPr/>
+        </p:nvSpPr>
+        <p:spPr>
+          <a:xfrm>
+            <a:off x="8366760" y="4855464"/>
+            <a:ext cx="1554480" cy="457200"/>
+          </a:xfrm>
+          <a:prstGeom prst="rect">
+            <a:avLst/>
+          </a:prstGeom>
+          <a:noFill/>
+        </p:spPr>
+        <p:txBody>
+          <a:bodyPr wrap="square" anchor="ctr">
+            <a:spAutoFit/>
+          </a:bodyPr>
+          <a:lstStyle/>
+          <a:p>
+            <a:pPr algn="l"/>
+            <a:r>
+              <a:rPr sz="1300" b="0" i="0">
+                <a:solidFill>
+                  <a:srgbClr val="444A52"/>
+                </a:solidFill>
+                <a:latin typeface="Calibri"/>
+              </a:rPr>
+              <a:t>Yuqori</a:t>
+            </a:r>
+          </a:p>
+        </p:txBody>
+      </p:sp>
+      <p:sp>
+        <p:nvSpPr>
+          <p:cNvPr id="39" name="TextBox 38"/>
+          <p:cNvSpPr txBox="1"/>
+          <p:nvPr/>
+        </p:nvSpPr>
+        <p:spPr>
+          <a:xfrm>
+            <a:off x="9921240" y="4855464"/>
+            <a:ext cx="1463040" cy="457200"/>
+          </a:xfrm>
+          <a:prstGeom prst="rect">
+            <a:avLst/>
+          </a:prstGeom>
+          <a:noFill/>
+        </p:spPr>
+        <p:txBody>
+          <a:bodyPr wrap="square" anchor="ctr">
+            <a:spAutoFit/>
+          </a:bodyPr>
+          <a:lstStyle/>
+          <a:p>
+            <a:pPr algn="l"/>
+            <a:r>
+              <a:rPr sz="1300" b="1" i="0">
+                <a:solidFill>
+                  <a:srgbClr val="1E8E5A"/>
+                </a:solidFill>
+                <a:latin typeface="Calibri"/>
+              </a:rPr>
+              <a:t>O'rtacha</a:t>
+            </a:r>
+          </a:p>
+        </p:txBody>
+      </p:sp>
+      <p:sp>
+        <p:nvSpPr>
+          <p:cNvPr id="40" name="TextBox 39"/>
+          <p:cNvSpPr txBox="1"/>
+          <p:nvPr/>
+        </p:nvSpPr>
+        <p:spPr>
+          <a:xfrm>
+            <a:off x="6537960" y="5422392"/>
+            <a:ext cx="1828800" cy="457200"/>
+          </a:xfrm>
+          <a:prstGeom prst="rect">
+            <a:avLst/>
+          </a:prstGeom>
+          <a:noFill/>
+        </p:spPr>
+        <p:txBody>
+          <a:bodyPr wrap="square" anchor="ctr">
+            <a:spAutoFit/>
+          </a:bodyPr>
+          <a:lstStyle/>
+          <a:p>
+            <a:pPr algn="l"/>
+            <a:r>
+              <a:rPr sz="1300" b="1" i="0">
+                <a:solidFill>
+                  <a:srgbClr val="444A52"/>
+                </a:solidFill>
+                <a:latin typeface="Calibri"/>
+              </a:rPr>
+              <a:t>IoT mosligi</a:t>
+            </a:r>
+          </a:p>
+        </p:txBody>
+      </p:sp>
+      <p:sp>
+        <p:nvSpPr>
+          <p:cNvPr id="41" name="TextBox 40"/>
+          <p:cNvSpPr txBox="1"/>
+          <p:nvPr/>
+        </p:nvSpPr>
+        <p:spPr>
+          <a:xfrm>
+            <a:off x="8366760" y="5422392"/>
+            <a:ext cx="1554480" cy="457200"/>
+          </a:xfrm>
+          <a:prstGeom prst="rect">
+            <a:avLst/>
+          </a:prstGeom>
+          <a:noFill/>
+        </p:spPr>
+        <p:txBody>
+          <a:bodyPr wrap="square" anchor="ctr">
+            <a:spAutoFit/>
+          </a:bodyPr>
+          <a:lstStyle/>
+          <a:p>
+            <a:pPr algn="l"/>
+            <a:r>
+              <a:rPr sz="1300" b="0" i="0">
+                <a:solidFill>
+                  <a:srgbClr val="444A52"/>
+                </a:solidFill>
+                <a:latin typeface="Calibri"/>
+              </a:rPr>
+              <a:t>Mos emas</a:t>
+            </a:r>
+          </a:p>
+        </p:txBody>
+      </p:sp>
+      <p:sp>
+        <p:nvSpPr>
+          <p:cNvPr id="42" name="TextBox 41"/>
+          <p:cNvSpPr txBox="1"/>
+          <p:nvPr/>
+        </p:nvSpPr>
+        <p:spPr>
+          <a:xfrm>
+            <a:off x="9921240" y="5422392"/>
+            <a:ext cx="1463040" cy="457200"/>
+          </a:xfrm>
+          <a:prstGeom prst="rect">
+            <a:avLst/>
+          </a:prstGeom>
+          <a:noFill/>
+        </p:spPr>
+        <p:txBody>
+          <a:bodyPr wrap="square" anchor="ctr">
+            <a:spAutoFit/>
+          </a:bodyPr>
+          <a:lstStyle/>
+          <a:p>
+            <a:pPr algn="l"/>
+            <a:r>
+              <a:rPr sz="1300" b="1" i="0">
+                <a:solidFill>
+                  <a:srgbClr val="1E8E5A"/>
+                </a:solidFill>
+                <a:latin typeface="Calibri"/>
+              </a:rPr>
+              <a:t>A'lo</a:t>
             </a:r>
           </a:p>
         </p:txBody>

</xml_diff>